<commit_message>
Align pitch pack and docs with invite-led pilot flow
Update outreach, leave-behind, HTML/PPTX decks, readiness, privacy,
security, engineering, and user-manual onboarding for /request-pilot
and platform School pilots provisioning.

Co-authored-by: AKHIL V S <akhil-vs@users.noreply.github.com>
</commit_message>
<xml_diff>
--- a/docs/pitch/School-Marks-Analytics-Principal-Pitch.pptx
+++ b/docs/pitch/School-Marks-Analytics-Principal-Pitch.pptx
@@ -3751,7 +3751,7 @@
                 <a:ea typeface="Calibri" pitchFamily="34" charset="-122"/>
                 <a:cs typeface="Calibri" pitchFamily="34" charset="-120"/>
               </a:rPr>
-              <a:t>Leadership insights &amp; audit trail</a:t>
+              <a:t>Leadership insights &amp; Curricular Hub</a:t>
             </a:r>
             <a:endParaRPr lang="en-US" sz="1400" dirty="0"/>
           </a:p>
@@ -3911,7 +3911,7 @@
                 <a:ea typeface="Calibri" pitchFamily="34" charset="-122"/>
                 <a:cs typeface="Calibri" pitchFamily="34" charset="-120"/>
               </a:rPr>
-              <a:t>Enter marks when covering gaps</a:t>
+              <a:t>Timetables, leave &amp; cover</a:t>
             </a:r>
             <a:endParaRPr lang="en-US" sz="1400" dirty="0"/>
           </a:p>
@@ -4641,7 +4641,7 @@
                 <a:ea typeface="Calibri" pitchFamily="34" charset="-122"/>
                 <a:cs typeface="Calibri" pitchFamily="34" charset="-120"/>
               </a:rPr>
-              <a:t>Class, subject, teacher, and year-on-year views — plus Deep insights for readiness, division gaps, and improvement cohorts.</a:t>
+              <a:t>Class, subject, teacher, and year-on-year views — plus Deep insights and the Curricular Performance Hub for readiness and board-facing reads.</a:t>
             </a:r>
             <a:endParaRPr lang="en-US" sz="1400" dirty="0"/>
           </a:p>
@@ -5304,7 +5304,7 @@
                 <a:ea typeface="Calibri" pitchFamily="34" charset="-122"/>
                 <a:cs typeface="Calibri" pitchFamily="34" charset="-120"/>
               </a:rPr>
-              <a:t>Pending uploads → approve → consolidated list → school letterhead &amp; staff join code.</a:t>
+              <a:t>Pending uploads → approve → consolidated list → letterhead, join code, and (optional) hall tickets.</a:t>
             </a:r>
             <a:endParaRPr lang="en-US" sz="1500" dirty="0"/>
           </a:p>
@@ -5423,7 +5423,7 @@
                 <a:ea typeface="Calibri" pitchFamily="34" charset="-122"/>
                 <a:cs typeface="Calibri" pitchFamily="34" charset="-120"/>
               </a:rPr>
-              <a:t>Objections, pilot scope, named champion, and a start date.</a:t>
+              <a:t>Objections, pilot scope, named champion, start date — or submit Request a school pilot on the site.</a:t>
             </a:r>
             <a:endParaRPr lang="en-US" sz="1500" dirty="0"/>
           </a:p>
@@ -5639,7 +5639,7 @@
         <p:spPr>
           <a:xfrm>
             <a:off x="640080" y="1371600"/>
-            <a:ext cx="10972800" cy="502920"/>
+            <a:ext cx="10972800" cy="640080"/>
           </a:xfrm>
           <a:prstGeom prst="rect">
             <a:avLst/>
@@ -5663,7 +5663,7 @@
                 <a:ea typeface="Calibri" pitchFamily="34" charset="-122"/>
                 <a:cs typeface="Calibri" pitchFamily="34" charset="-120"/>
               </a:rPr>
-              <a:t>One grade or section set. Your exam co-ordinator owns the calendar and approvals. One class teacher enters marks. We support setup in week one.</a:t>
+              <a:t>Invite-led campus (not open public signup). One grade or section set. Your exam co-ordinator owns the calendar and approvals. We provision the school after you request a pilot — then support setup in week one.</a:t>
             </a:r>
             <a:endParaRPr lang="en-US" sz="1500" dirty="0"/>
           </a:p>
@@ -5677,12 +5677,12 @@
         </p:nvSpPr>
         <p:spPr>
           <a:xfrm>
-            <a:off x="640080" y="2103120"/>
-            <a:ext cx="5394960" cy="3840480"/>
+            <a:off x="640080" y="2194560"/>
+            <a:ext cx="5394960" cy="3749040"/>
           </a:xfrm>
           <a:prstGeom prst="roundRect">
             <a:avLst>
-              <a:gd name="adj" fmla="val 2857"/>
+              <a:gd name="adj" fmla="val 2927"/>
             </a:avLst>
           </a:prstGeom>
           <a:solidFill>
@@ -5704,7 +5704,7 @@
         </p:nvSpPr>
         <p:spPr>
           <a:xfrm>
-            <a:off x="868680" y="2331720"/>
+            <a:off x="868680" y="2423160"/>
             <a:ext cx="4937760" cy="365760"/>
           </a:xfrm>
           <a:prstGeom prst="rect">
@@ -5743,7 +5743,7 @@
         </p:nvSpPr>
         <p:spPr>
           <a:xfrm>
-            <a:off x="868680" y="2926080"/>
+            <a:off x="868680" y="3017520"/>
             <a:ext cx="4937760" cy="2560320"/>
           </a:xfrm>
           <a:prstGeom prst="rect">
@@ -5819,12 +5819,12 @@
         </p:nvSpPr>
         <p:spPr>
           <a:xfrm>
-            <a:off x="6263640" y="2103120"/>
-            <a:ext cx="5394960" cy="3840480"/>
+            <a:off x="6263640" y="2194560"/>
+            <a:ext cx="5394960" cy="3749040"/>
           </a:xfrm>
           <a:prstGeom prst="roundRect">
             <a:avLst>
-              <a:gd name="adj" fmla="val 2857"/>
+              <a:gd name="adj" fmla="val 2927"/>
             </a:avLst>
           </a:prstGeom>
           <a:solidFill>
@@ -5846,7 +5846,7 @@
         </p:nvSpPr>
         <p:spPr>
           <a:xfrm>
-            <a:off x="6492240" y="2331720"/>
+            <a:off x="6492240" y="2423160"/>
             <a:ext cx="4937760" cy="365760"/>
           </a:xfrm>
           <a:prstGeom prst="rect">
@@ -5871,7 +5871,7 @@
                 <a:ea typeface="Georgia" pitchFamily="34" charset="-122"/>
                 <a:cs typeface="Georgia" pitchFamily="34" charset="-120"/>
               </a:rPr>
-              <a:t>What we need from you</a:t>
+              <a:t>How we start</a:t>
             </a:r>
             <a:endParaRPr lang="en-US" sz="1800" dirty="0"/>
           </a:p>
@@ -5885,7 +5885,7 @@
         </p:nvSpPr>
         <p:spPr>
           <a:xfrm>
-            <a:off x="6492240" y="2926080"/>
+            <a:off x="6492240" y="3017520"/>
             <a:ext cx="4937760" cy="2560320"/>
           </a:xfrm>
           <a:prstGeom prst="rect">
@@ -5911,7 +5911,7 @@
                 <a:ea typeface="Calibri" pitchFamily="34" charset="-122"/>
                 <a:cs typeface="Calibri" pitchFamily="34" charset="-120"/>
               </a:rPr>
-              <a:t>Pilot start date and exam name</a:t>
+              <a:t>Submit Request a school pilot on the product site</a:t>
             </a:r>
             <a:endParaRPr lang="en-US" sz="1500" dirty="0"/>
           </a:p>
@@ -5929,7 +5929,7 @@
                 <a:ea typeface="Calibri" pitchFamily="34" charset="-122"/>
                 <a:cs typeface="Calibri" pitchFamily="34" charset="-120"/>
               </a:rPr>
-              <a:t>Classes / sections in scope</a:t>
+              <a:t>We review and provision a private campus</a:t>
             </a:r>
             <a:endParaRPr lang="en-US" sz="1500" dirty="0"/>
           </a:p>
@@ -5947,7 +5947,7 @@
                 <a:ea typeface="Calibri" pitchFamily="34" charset="-122"/>
                 <a:cs typeface="Calibri" pitchFamily="34" charset="-120"/>
               </a:rPr>
-              <a:t>Named co-ordinator + one class teacher</a:t>
+              <a:t>You receive principal login + staff join code</a:t>
             </a:r>
             <a:endParaRPr lang="en-US" sz="1500" dirty="0"/>
           </a:p>
@@ -5965,7 +5965,7 @@
                 <a:ea typeface="Calibri" pitchFamily="34" charset="-122"/>
                 <a:cs typeface="Calibri" pitchFamily="34" charset="-120"/>
               </a:rPr>
-              <a:t>School display name and logo for letterhead</a:t>
+              <a:t>Confirm exam, classes, co-ordinator, and logo</a:t>
             </a:r>
             <a:endParaRPr lang="en-US" sz="1500" dirty="0"/>
           </a:p>
@@ -6291,7 +6291,7 @@
                 <a:ea typeface="Calibri" pitchFamily="34" charset="-122"/>
                 <a:cs typeface="Calibri" pitchFamily="34" charset="-120"/>
               </a:rPr>
-              <a:t>Nominate the principal and exam co-ordinator as leadership accounts.</a:t>
+              <a:t>Submit or confirm a school pilot request so we can provision your private campus.</a:t>
             </a:r>
             <a:endParaRPr lang="en-US" sz="1500" dirty="0"/>
           </a:p>
@@ -6416,7 +6416,7 @@
                 <a:ea typeface="Calibri" pitchFamily="34" charset="-122"/>
                 <a:cs typeface="Calibri" pitchFamily="34" charset="-120"/>
               </a:rPr>
-              <a:t>Confirm board grading rules — pass percent, distinction, grade bands.</a:t>
+              <a:t>Nominate the principal and exam co-ordinator; share the staff join code with teachers.</a:t>
             </a:r>
             <a:endParaRPr lang="en-US" sz="1500" dirty="0"/>
           </a:p>
@@ -6541,7 +6541,7 @@
                 <a:ea typeface="Calibri" pitchFamily="34" charset="-122"/>
                 <a:cs typeface="Calibri" pitchFamily="34" charset="-120"/>
               </a:rPr>
-              <a:t>Schedule a setup window for classes, subjects, roll, and teacher assignments.</a:t>
+              <a:t>Schedule a setup window for profile, classes, subjects, roll, and teacher assignments.</a:t>
             </a:r>
             <a:endParaRPr lang="en-US" sz="1500" dirty="0"/>
           </a:p>

</xml_diff>

<commit_message>
Align pitch pack and docs with invite-led pilot flow (#179)
Update outreach, leave-behind, HTML/PPTX decks, readiness, privacy,
security, engineering, and user-manual onboarding for /request-pilot
and platform School pilots provisioning.

Co-authored-by: Cursor Agent <cursoragent@cursor.com>
Co-authored-by: AKHIL V S <akhil-vs@users.noreply.github.com>
</commit_message>
<xml_diff>
--- a/docs/pitch/School-Marks-Analytics-Principal-Pitch.pptx
+++ b/docs/pitch/School-Marks-Analytics-Principal-Pitch.pptx
@@ -3751,7 +3751,7 @@
                 <a:ea typeface="Calibri" pitchFamily="34" charset="-122"/>
                 <a:cs typeface="Calibri" pitchFamily="34" charset="-120"/>
               </a:rPr>
-              <a:t>Leadership insights &amp; audit trail</a:t>
+              <a:t>Leadership insights &amp; Curricular Hub</a:t>
             </a:r>
             <a:endParaRPr lang="en-US" sz="1400" dirty="0"/>
           </a:p>
@@ -3911,7 +3911,7 @@
                 <a:ea typeface="Calibri" pitchFamily="34" charset="-122"/>
                 <a:cs typeface="Calibri" pitchFamily="34" charset="-120"/>
               </a:rPr>
-              <a:t>Enter marks when covering gaps</a:t>
+              <a:t>Timetables, leave &amp; cover</a:t>
             </a:r>
             <a:endParaRPr lang="en-US" sz="1400" dirty="0"/>
           </a:p>
@@ -4641,7 +4641,7 @@
                 <a:ea typeface="Calibri" pitchFamily="34" charset="-122"/>
                 <a:cs typeface="Calibri" pitchFamily="34" charset="-120"/>
               </a:rPr>
-              <a:t>Class, subject, teacher, and year-on-year views — plus Deep insights for readiness, division gaps, and improvement cohorts.</a:t>
+              <a:t>Class, subject, teacher, and year-on-year views — plus Deep insights and the Curricular Performance Hub for readiness and board-facing reads.</a:t>
             </a:r>
             <a:endParaRPr lang="en-US" sz="1400" dirty="0"/>
           </a:p>
@@ -5304,7 +5304,7 @@
                 <a:ea typeface="Calibri" pitchFamily="34" charset="-122"/>
                 <a:cs typeface="Calibri" pitchFamily="34" charset="-120"/>
               </a:rPr>
-              <a:t>Pending uploads → approve → consolidated list → school letterhead &amp; staff join code.</a:t>
+              <a:t>Pending uploads → approve → consolidated list → letterhead, join code, and (optional) hall tickets.</a:t>
             </a:r>
             <a:endParaRPr lang="en-US" sz="1500" dirty="0"/>
           </a:p>
@@ -5423,7 +5423,7 @@
                 <a:ea typeface="Calibri" pitchFamily="34" charset="-122"/>
                 <a:cs typeface="Calibri" pitchFamily="34" charset="-120"/>
               </a:rPr>
-              <a:t>Objections, pilot scope, named champion, and a start date.</a:t>
+              <a:t>Objections, pilot scope, named champion, start date — or submit Request a school pilot on the site.</a:t>
             </a:r>
             <a:endParaRPr lang="en-US" sz="1500" dirty="0"/>
           </a:p>
@@ -5639,7 +5639,7 @@
         <p:spPr>
           <a:xfrm>
             <a:off x="640080" y="1371600"/>
-            <a:ext cx="10972800" cy="502920"/>
+            <a:ext cx="10972800" cy="640080"/>
           </a:xfrm>
           <a:prstGeom prst="rect">
             <a:avLst/>
@@ -5663,7 +5663,7 @@
                 <a:ea typeface="Calibri" pitchFamily="34" charset="-122"/>
                 <a:cs typeface="Calibri" pitchFamily="34" charset="-120"/>
               </a:rPr>
-              <a:t>One grade or section set. Your exam co-ordinator owns the calendar and approvals. One class teacher enters marks. We support setup in week one.</a:t>
+              <a:t>Invite-led campus (not open public signup). One grade or section set. Your exam co-ordinator owns the calendar and approvals. We provision the school after you request a pilot — then support setup in week one.</a:t>
             </a:r>
             <a:endParaRPr lang="en-US" sz="1500" dirty="0"/>
           </a:p>
@@ -5677,12 +5677,12 @@
         </p:nvSpPr>
         <p:spPr>
           <a:xfrm>
-            <a:off x="640080" y="2103120"/>
-            <a:ext cx="5394960" cy="3840480"/>
+            <a:off x="640080" y="2194560"/>
+            <a:ext cx="5394960" cy="3749040"/>
           </a:xfrm>
           <a:prstGeom prst="roundRect">
             <a:avLst>
-              <a:gd name="adj" fmla="val 2857"/>
+              <a:gd name="adj" fmla="val 2927"/>
             </a:avLst>
           </a:prstGeom>
           <a:solidFill>
@@ -5704,7 +5704,7 @@
         </p:nvSpPr>
         <p:spPr>
           <a:xfrm>
-            <a:off x="868680" y="2331720"/>
+            <a:off x="868680" y="2423160"/>
             <a:ext cx="4937760" cy="365760"/>
           </a:xfrm>
           <a:prstGeom prst="rect">
@@ -5743,7 +5743,7 @@
         </p:nvSpPr>
         <p:spPr>
           <a:xfrm>
-            <a:off x="868680" y="2926080"/>
+            <a:off x="868680" y="3017520"/>
             <a:ext cx="4937760" cy="2560320"/>
           </a:xfrm>
           <a:prstGeom prst="rect">
@@ -5819,12 +5819,12 @@
         </p:nvSpPr>
         <p:spPr>
           <a:xfrm>
-            <a:off x="6263640" y="2103120"/>
-            <a:ext cx="5394960" cy="3840480"/>
+            <a:off x="6263640" y="2194560"/>
+            <a:ext cx="5394960" cy="3749040"/>
           </a:xfrm>
           <a:prstGeom prst="roundRect">
             <a:avLst>
-              <a:gd name="adj" fmla="val 2857"/>
+              <a:gd name="adj" fmla="val 2927"/>
             </a:avLst>
           </a:prstGeom>
           <a:solidFill>
@@ -5846,7 +5846,7 @@
         </p:nvSpPr>
         <p:spPr>
           <a:xfrm>
-            <a:off x="6492240" y="2331720"/>
+            <a:off x="6492240" y="2423160"/>
             <a:ext cx="4937760" cy="365760"/>
           </a:xfrm>
           <a:prstGeom prst="rect">
@@ -5871,7 +5871,7 @@
                 <a:ea typeface="Georgia" pitchFamily="34" charset="-122"/>
                 <a:cs typeface="Georgia" pitchFamily="34" charset="-120"/>
               </a:rPr>
-              <a:t>What we need from you</a:t>
+              <a:t>How we start</a:t>
             </a:r>
             <a:endParaRPr lang="en-US" sz="1800" dirty="0"/>
           </a:p>
@@ -5885,7 +5885,7 @@
         </p:nvSpPr>
         <p:spPr>
           <a:xfrm>
-            <a:off x="6492240" y="2926080"/>
+            <a:off x="6492240" y="3017520"/>
             <a:ext cx="4937760" cy="2560320"/>
           </a:xfrm>
           <a:prstGeom prst="rect">
@@ -5911,7 +5911,7 @@
                 <a:ea typeface="Calibri" pitchFamily="34" charset="-122"/>
                 <a:cs typeface="Calibri" pitchFamily="34" charset="-120"/>
               </a:rPr>
-              <a:t>Pilot start date and exam name</a:t>
+              <a:t>Submit Request a school pilot on the product site</a:t>
             </a:r>
             <a:endParaRPr lang="en-US" sz="1500" dirty="0"/>
           </a:p>
@@ -5929,7 +5929,7 @@
                 <a:ea typeface="Calibri" pitchFamily="34" charset="-122"/>
                 <a:cs typeface="Calibri" pitchFamily="34" charset="-120"/>
               </a:rPr>
-              <a:t>Classes / sections in scope</a:t>
+              <a:t>We review and provision a private campus</a:t>
             </a:r>
             <a:endParaRPr lang="en-US" sz="1500" dirty="0"/>
           </a:p>
@@ -5947,7 +5947,7 @@
                 <a:ea typeface="Calibri" pitchFamily="34" charset="-122"/>
                 <a:cs typeface="Calibri" pitchFamily="34" charset="-120"/>
               </a:rPr>
-              <a:t>Named co-ordinator + one class teacher</a:t>
+              <a:t>You receive principal login + staff join code</a:t>
             </a:r>
             <a:endParaRPr lang="en-US" sz="1500" dirty="0"/>
           </a:p>
@@ -5965,7 +5965,7 @@
                 <a:ea typeface="Calibri" pitchFamily="34" charset="-122"/>
                 <a:cs typeface="Calibri" pitchFamily="34" charset="-120"/>
               </a:rPr>
-              <a:t>School display name and logo for letterhead</a:t>
+              <a:t>Confirm exam, classes, co-ordinator, and logo</a:t>
             </a:r>
             <a:endParaRPr lang="en-US" sz="1500" dirty="0"/>
           </a:p>
@@ -6291,7 +6291,7 @@
                 <a:ea typeface="Calibri" pitchFamily="34" charset="-122"/>
                 <a:cs typeface="Calibri" pitchFamily="34" charset="-120"/>
               </a:rPr>
-              <a:t>Nominate the principal and exam co-ordinator as leadership accounts.</a:t>
+              <a:t>Submit or confirm a school pilot request so we can provision your private campus.</a:t>
             </a:r>
             <a:endParaRPr lang="en-US" sz="1500" dirty="0"/>
           </a:p>
@@ -6416,7 +6416,7 @@
                 <a:ea typeface="Calibri" pitchFamily="34" charset="-122"/>
                 <a:cs typeface="Calibri" pitchFamily="34" charset="-120"/>
               </a:rPr>
-              <a:t>Confirm board grading rules — pass percent, distinction, grade bands.</a:t>
+              <a:t>Nominate the principal and exam co-ordinator; share the staff join code with teachers.</a:t>
             </a:r>
             <a:endParaRPr lang="en-US" sz="1500" dirty="0"/>
           </a:p>
@@ -6541,7 +6541,7 @@
                 <a:ea typeface="Calibri" pitchFamily="34" charset="-122"/>
                 <a:cs typeface="Calibri" pitchFamily="34" charset="-120"/>
               </a:rPr>
-              <a:t>Schedule a setup window for classes, subjects, roll, and teacher assignments.</a:t>
+              <a:t>Schedule a setup window for profile, classes, subjects, roll, and teacher assignments.</a:t>
             </a:r>
             <a:endParaRPr lang="en-US" sz="1500" dirty="0"/>
           </a:p>

</xml_diff>